<commit_message>
feat: runner and documentation updates
</commit_message>
<xml_diff>
--- a/sql-as-software-getting-started-with-dbt.pptx
+++ b/sql-as-software-getting-started-with-dbt.pptx
@@ -4129,7 +4129,7 @@
           <a:p/>
           <a:p>
             <a:r>
-              <a:t>Demo 4. Switch to .venv-lakehouse and run dbt build --target lakehouse; the profile's lakehouse output points at LH_Jaffle_Shop (schema-enabled, schema jaffle_shop). Show the same model files. Run dbt build against the pre-seeded raw tables; show the generated relation name and query the Delta table in a notebook or the SQL endpoint: 6 new, 929 returning, total 671,425.37. Use a rehearsed recording if the session is not ready within 20 seconds. Be explicit that data was seeded separately and the SQL was designed to be compatible.</a:t>
+              <a:t>Demo 4. Switch to .venv-lakehouse and run dbt build --select customers --target lakehouse (measured 1 min 57 s). Do not run the full project live: every Spark statement costs ~20 s over Livy, so 48 nodes take 7.5 min even with 4 threads - run it before the talk and use that as the recording. The profile's lakehouse output points at LH_Jaffle_Shop (schema-enabled, schema jaffle_shop). Show the same model files, then the compiled customers.sql side by side with the Warehouse version: backticks vs brackets, coalesce(..., false) vs cast(... as bit), decimal vs numeric. Query the Delta table in a notebook or the SQL endpoint: 6 new, 929 returning, total 671,425.37. Use the recording if the session is not ready within 20 seconds. Be explicit that the raw tables were loaded into the Lakehouse separately (CSV upload, Load to table) and that the SQL was designed to be compatible.</a:t>
             </a:r>
           </a:p>
           <a:p/>
@@ -20482,7 +20482,7 @@
                 <a:latin typeface="Frutiger"/>
                 <a:cs typeface="Frutiger"/>
               </a:rPr>
-              <a:t>expression_is_true fails on stg_orders for all 61,948 rows; order_items, orders and customers are SKIPPED. The old tables are still there — no rollback.</a:t>
+              <a:t>expression_is_true fails on stg_orders for 61,465 of 61,948 rows (the rest carry no tax); order_items, orders and customers are SKIPPED. The old tables are still there — no rollback.</a:t>
             </a:r>
           </a:p>
         </p:txBody>
@@ -20711,7 +20711,7 @@
                 <a:latin typeface="Consolas"/>
                 <a:cs typeface="Consolas"/>
               </a:rPr>
-              <a:t>FAIL 61948 </a:t>
+              <a:t>FAIL 61465 </a:t>
             </a:r>
             <a:r>
               <a:rPr lang="en-US" sz="1500" dirty="0">
@@ -20795,7 +20795,7 @@
                 <a:latin typeface="Consolas"/>
                 <a:cs typeface="Consolas"/>
               </a:rPr>
-              <a:t>Done. PASS=4 ERROR=1 SKIP=17 TOTAL=22</a:t>
+              <a:t>Done. PASS=4 WARN=0 ERROR=1 SKIP=17 TOTAL=22</a:t>
             </a:r>
           </a:p>
           <a:p>
@@ -29280,7 +29280,7 @@
                 <a:latin typeface="Frutiger"/>
                 <a:cs typeface="Frutiger"/>
               </a:rPr>
-              <a:t>dbt build on Spark  </a:t>
+              <a:t>dbt build --select customers  </a:t>
             </a:r>
             <a:r>
               <a:rPr lang="en-US" sz="1900" dirty="0">
@@ -29290,7 +29290,7 @@
                 <a:latin typeface="Frutiger"/>
                 <a:cs typeface="Frutiger"/>
               </a:rPr>
-              <a:t>Against the pre-seeded Lakehouse with a warm Livy session. If Spark is slow, the rehearsed recording plays.</a:t>
+              <a:t>One mart and its four tests on Spark, ~2 minutes with a warm Livy session. The full 48-node build (~7 min) is the recording.</a:t>
             </a:r>
           </a:p>
         </p:txBody>
@@ -29814,6 +29814,26 @@
                 <a:cs typeface="Consolas"/>
               </a:rPr>
               <a:t>true</a:t>
+            </a:r>
+            <a:r>
+              <a:rPr lang="en-US" sz="1300" dirty="0">
+                <a:solidFill>
+                  <a:srgbClr val="FFD27F"/>
+                </a:solidFill>
+                <a:latin typeface="Consolas"/>
+                <a:cs typeface="Consolas"/>
+              </a:rPr>
+              <a:t>     threads: </a:t>
+            </a:r>
+            <a:r>
+              <a:rPr lang="en-US" sz="1300" dirty="0">
+                <a:solidFill>
+                  <a:srgbClr val="FFD27F"/>
+                </a:solidFill>
+                <a:latin typeface="Consolas"/>
+                <a:cs typeface="Consolas"/>
+              </a:rPr>
+              <a:t>4</a:t>
             </a:r>
           </a:p>
         </p:txBody>
@@ -32283,7 +32303,7 @@
                 <a:latin typeface="Consolas"/>
                 <a:cs typeface="Consolas"/>
               </a:rPr>
-              <a:t>  encrypt: </a:t>
+              <a:t>  schema_authorization: </a:t>
             </a:r>
             <a:r>
               <a:rPr lang="en-US" sz="1300" dirty="0">
@@ -32293,7 +32313,7 @@
                 <a:latin typeface="Consolas"/>
                 <a:cs typeface="Consolas"/>
               </a:rPr>
-              <a:t>true</a:t>
+              <a:t>dbo</a:t>
             </a:r>
             <a:r>
               <a:rPr lang="en-US" sz="1300" dirty="0">
@@ -32303,12 +32323,50 @@
                 <a:latin typeface="Consolas"/>
                 <a:cs typeface="Consolas"/>
               </a:rPr>
+              <a:t>   # workspace identities are not db users</a:t>
+            </a:r>
+          </a:p>
+          <a:p>
+            <a:pPr>
+              <a:lnSpc>
+                <a:spcPct val="118000"/>
+              </a:lnSpc>
+              <a:buNone/>
+            </a:pPr>
+            <a:r>
+              <a:rPr lang="en-US" sz="1300" dirty="0">
+                <a:solidFill>
+                  <a:srgbClr val="8EC5FF"/>
+                </a:solidFill>
+                <a:latin typeface="Consolas"/>
+                <a:cs typeface="Consolas"/>
+              </a:rPr>
+              <a:t>  encrypt: </a:t>
+            </a:r>
+            <a:r>
+              <a:rPr lang="en-US" sz="1300" dirty="0">
+                <a:solidFill>
+                  <a:srgbClr val="FFD27F"/>
+                </a:solidFill>
+                <a:latin typeface="Consolas"/>
+                <a:cs typeface="Consolas"/>
+              </a:rPr>
+              <a:t>true</a:t>
+            </a:r>
+            <a:r>
+              <a:rPr lang="en-US" sz="1300" dirty="0">
+                <a:solidFill>
+                  <a:srgbClr val="8EC5FF"/>
+                </a:solidFill>
+                <a:latin typeface="Consolas"/>
+                <a:cs typeface="Consolas"/>
+              </a:rPr>
               <a:t>   trust_cert: </a:t>
             </a:r>
             <a:r>
               <a:rPr lang="en-US" sz="1300" dirty="0">
                 <a:solidFill>
-                  <a:srgbClr val="FFD27F"/>
+                  <a:srgbClr val="8EC5FF"/>
                 </a:solidFill>
                 <a:latin typeface="Consolas"/>
                 <a:cs typeface="Consolas"/>
@@ -52086,7 +52144,7 @@
                 <a:latin typeface="Consolas"/>
                 <a:cs typeface="Consolas"/>
               </a:rPr>
-              <a:t>from "WH_Jaffle_Shop"."raw"."raw_orders"</a:t>
+              <a:t>from [WH_Jaffle_Shop].[raw].[raw_orders]</a:t>
             </a:r>
             <a:r>
               <a:rPr lang="en-US" sz="1800" i="1" dirty="0">

</xml_diff>

<commit_message>
fix: remove lock file
</commit_message>
<xml_diff>
--- a/sql-as-software-getting-started-with-dbt.pptx
+++ b/sql-as-software-getting-started-with-dbt.pptx
@@ -14795,57 +14795,6 @@
       </p:grpSpPr>
       <p:sp>
         <p:nvSpPr>
-          <p:cNvPr id="2" name="Text 0">
-            <a:extLst>
-              <a:ext uri="{FF2B5EF4-FFF2-40B4-BE49-F238E27FC236}">
-                <a16:creationId xmlns:a16="http://schemas.microsoft.com/office/drawing/2014/main" id="{53AA81A4-4B55-4071-8D0D-8E66DAC85BE0}"/>
-              </a:ext>
-            </a:extLst>
-          </p:cNvPr>
-          <p:cNvSpPr>
-            <a:spLocks noGrp="1"/>
-          </p:cNvSpPr>
-          <p:nvPr/>
-        </p:nvSpPr>
-        <p:spPr>
-          <a:xfrm>
-            <a:off x="838201" y="495302"/>
-            <a:ext cx="15240000" cy="392311"/>
-          </a:xfrm>
-          <a:prstGeom prst="rect">
-            <a:avLst/>
-          </a:prstGeom>
-          <a:noFill/>
-        </p:spPr>
-        <p:txBody>
-          <a:bodyPr wrap="square" lIns="25401" tIns="25401" rIns="25401" bIns="25401" anchor="t">
-            <a:normAutofit/>
-          </a:bodyPr>
-          <a:lstStyle/>
-          <a:p>
-            <a:pPr>
-              <a:lnSpc>
-                <a:spcPct val="120000"/>
-              </a:lnSpc>
-              <a:buNone/>
-            </a:pPr>
-            <a:r>
-              <a:rPr sz="1801" b="1" spc="361">
-                <a:solidFill>
-                  <a:srgbClr val="E40046"/>
-                </a:solidFill>
-                <a:latin typeface="Frutiger"/>
-                <a:ea typeface="Frutiger"/>
-                <a:cs typeface="Frutiger"/>
-              </a:rPr>
-              <a:t>ANATOMY OF A PROJECT</a:t>
-            </a:r>
-            <a:endParaRPr sz="1801"/>
-          </a:p>
-        </p:txBody>
-      </p:sp>
-      <p:sp>
-        <p:nvSpPr>
           <p:cNvPr id="3" name="Text 1">
             <a:extLst>
               <a:ext uri="{FF2B5EF4-FFF2-40B4-BE49-F238E27FC236}">
@@ -14881,7 +14830,7 @@
               <a:buNone/>
             </a:pPr>
             <a:r>
-              <a:rPr sz="4651" b="1" spc="-69" dirty="0">
+              <a:rPr lang="en-US" sz="4651" b="1" spc="-69" dirty="0">
                 <a:solidFill>
                   <a:srgbClr val="001F6B"/>
                 </a:solidFill>
@@ -14889,7 +14838,7 @@
                 <a:ea typeface="Frutiger"/>
                 <a:cs typeface="Frutiger"/>
               </a:rPr>
-              <a:t>A folder of SQL and YAML — that’s the whole thing</a:t>
+              <a:t>Anatomy of a dbt project</a:t>
             </a:r>
             <a:endParaRPr sz="4651" dirty="0"/>
           </a:p>
@@ -16045,57 +15994,6 @@
       </p:grpSpPr>
       <p:sp>
         <p:nvSpPr>
-          <p:cNvPr id="2" name="Text 0">
-            <a:extLst>
-              <a:ext uri="{FF2B5EF4-FFF2-40B4-BE49-F238E27FC236}">
-                <a16:creationId xmlns:a16="http://schemas.microsoft.com/office/drawing/2014/main" id="{78DD8E74-1DB1-4509-B6B8-8F85DE69EC33}"/>
-              </a:ext>
-            </a:extLst>
-          </p:cNvPr>
-          <p:cNvSpPr>
-            <a:spLocks noGrp="1"/>
-          </p:cNvSpPr>
-          <p:nvPr/>
-        </p:nvSpPr>
-        <p:spPr>
-          <a:xfrm>
-            <a:off x="838201" y="495302"/>
-            <a:ext cx="15240000" cy="392311"/>
-          </a:xfrm>
-          <a:prstGeom prst="rect">
-            <a:avLst/>
-          </a:prstGeom>
-          <a:noFill/>
-        </p:spPr>
-        <p:txBody>
-          <a:bodyPr wrap="square" lIns="25401" tIns="25401" rIns="25401" bIns="25401" anchor="t">
-            <a:normAutofit/>
-          </a:bodyPr>
-          <a:lstStyle/>
-          <a:p>
-            <a:pPr>
-              <a:lnSpc>
-                <a:spcPct val="120000"/>
-              </a:lnSpc>
-              <a:buNone/>
-            </a:pPr>
-            <a:r>
-              <a:rPr sz="1801" b="1" spc="361">
-                <a:solidFill>
-                  <a:srgbClr val="E40046"/>
-                </a:solidFill>
-                <a:latin typeface="Frutiger"/>
-                <a:ea typeface="Frutiger"/>
-                <a:cs typeface="Frutiger"/>
-              </a:rPr>
-              <a:t>MODELS</a:t>
-            </a:r>
-            <a:endParaRPr sz="1801"/>
-          </a:p>
-        </p:txBody>
-      </p:sp>
-      <p:sp>
-        <p:nvSpPr>
           <p:cNvPr id="3" name="Text 1">
             <a:extLst>
               <a:ext uri="{FF2B5EF4-FFF2-40B4-BE49-F238E27FC236}">
@@ -16131,7 +16029,7 @@
               <a:buNone/>
             </a:pPr>
             <a:r>
-              <a:rPr sz="4651" b="1" spc="-69">
+              <a:rPr sz="4651" b="1" spc="-69" dirty="0">
                 <a:solidFill>
                   <a:srgbClr val="001F6B"/>
                 </a:solidFill>
@@ -16139,9 +16037,20 @@
                 <a:ea typeface="Frutiger"/>
                 <a:cs typeface="Frutiger"/>
               </a:rPr>
-              <a:t>A model is just a SELECT</a:t>
-            </a:r>
-            <a:endParaRPr sz="4651"/>
+              <a:t>A model is a SELECT</a:t>
+            </a:r>
+            <a:r>
+              <a:rPr lang="en-US" sz="4651" b="1" spc="-69" dirty="0">
+                <a:solidFill>
+                  <a:srgbClr val="001F6B"/>
+                </a:solidFill>
+                <a:latin typeface="Frutiger"/>
+                <a:ea typeface="Frutiger"/>
+                <a:cs typeface="Frutiger"/>
+              </a:rPr>
+              <a:t> statement</a:t>
+            </a:r>
+            <a:endParaRPr sz="4651" dirty="0"/>
           </a:p>
         </p:txBody>
       </p:sp>
@@ -18643,47 +18552,6 @@
       </p:graphicFrame>
       <p:sp>
         <p:nvSpPr>
-          <p:cNvPr id="110" name="Shape 110"/>
-          <p:cNvSpPr/>
-          <p:nvPr/>
-        </p:nvSpPr>
-        <p:spPr>
-          <a:xfrm>
-            <a:off x="12700000" y="2362200"/>
-            <a:ext cx="4749800" cy="355600"/>
-          </a:xfrm>
-          <a:prstGeom prst="rect">
-            <a:avLst/>
-          </a:prstGeom>
-          <a:noFill/>
-          <a:ln>
-            <a:noFill/>
-          </a:ln>
-        </p:spPr>
-        <p:txBody>
-          <a:bodyPr wrap="square" lIns="0" tIns="0" rIns="0" bIns="0" anchor="t">
-            <a:normAutofit/>
-          </a:bodyPr>
-          <a:lstStyle/>
-          <a:p>
-            <a:pPr>
-              <a:buNone/>
-            </a:pPr>
-            <a:r>
-              <a:rPr lang="en-US" sz="1400" b="1" spc="150" dirty="0">
-                <a:solidFill>
-                  <a:srgbClr val="E40046"/>
-                </a:solidFill>
-                <a:latin typeface="Frutiger"/>
-                <a:cs typeface="Frutiger"/>
-              </a:rPr>
-              <a:t>SET IT ONCE, PER FOLDER</a:t>
-            </a:r>
-          </a:p>
-        </p:txBody>
-      </p:sp>
-      <p:sp>
-        <p:nvSpPr>
           <p:cNvPr id="111" name="Code 111"/>
           <p:cNvSpPr/>
           <p:nvPr/>
@@ -18911,7 +18779,7 @@
                 <a:latin typeface="Frutiger"/>
                 <a:cs typeface="Frutiger"/>
               </a:rPr>
-              <a:t>…OR OVERRIDE IN ONE MODEL</a:t>
+              <a:t>MODELS CAN OVERRIDE THE DEFAULT</a:t>
             </a:r>
           </a:p>
         </p:txBody>
@@ -19111,7 +18979,7 @@
                 <a:latin typeface="Frutiger"/>
                 <a:cs typeface="Frutiger"/>
               </a:rPr>
-              <a:t>materialized_view and friends are adapter-specific — check before you promise them.</a:t>
+              <a:t>Some materializations are adapter-specific. See what your chosen adapter supports.</a:t>
             </a:r>
           </a:p>
         </p:txBody>
@@ -21483,7 +21351,7 @@
                 <a:latin typeface="Frutiger"/>
                 <a:cs typeface="Frutiger"/>
               </a:rPr>
-              <a:t>MODELS/MARTS/CUSTOMERS.YML  ·  THE FILE THAT SITS NEXT TO CUSTOMERS.SQL</a:t>
+              <a:t>MODELS/MARTS/CUSTOMERS.YML</a:t>
             </a:r>
           </a:p>
         </p:txBody>
@@ -22517,57 +22385,6 @@
       </p:grpSpPr>
       <p:sp>
         <p:nvSpPr>
-          <p:cNvPr id="2" name="Text 0">
-            <a:extLst>
-              <a:ext uri="{FF2B5EF4-FFF2-40B4-BE49-F238E27FC236}">
-                <a16:creationId xmlns:a16="http://schemas.microsoft.com/office/drawing/2014/main" id="{78DD8E74-1DB1-4509-B6B8-8F85DE69EC33}"/>
-              </a:ext>
-            </a:extLst>
-          </p:cNvPr>
-          <p:cNvSpPr>
-            <a:spLocks noGrp="1"/>
-          </p:cNvSpPr>
-          <p:nvPr/>
-        </p:nvSpPr>
-        <p:spPr>
-          <a:xfrm>
-            <a:off x="838201" y="495302"/>
-            <a:ext cx="15240000" cy="392311"/>
-          </a:xfrm>
-          <a:prstGeom prst="rect">
-            <a:avLst/>
-          </a:prstGeom>
-          <a:noFill/>
-        </p:spPr>
-        <p:txBody>
-          <a:bodyPr wrap="square" lIns="25401" tIns="25401" rIns="25401" bIns="25401" anchor="t">
-            <a:normAutofit/>
-          </a:bodyPr>
-          <a:lstStyle/>
-          <a:p>
-            <a:pPr>
-              <a:lnSpc>
-                <a:spcPct val="120000"/>
-              </a:lnSpc>
-              <a:buNone/>
-            </a:pPr>
-            <a:r>
-              <a:rPr sz="1801" b="1" spc="361">
-                <a:solidFill>
-                  <a:srgbClr val="E40046"/>
-                </a:solidFill>
-                <a:latin typeface="Frutiger"/>
-                <a:ea typeface="Frutiger"/>
-                <a:cs typeface="Frutiger"/>
-              </a:rPr>
-              <a:t>TESTS</a:t>
-            </a:r>
-            <a:endParaRPr sz="1801"/>
-          </a:p>
-        </p:txBody>
-      </p:sp>
-      <p:sp>
-        <p:nvSpPr>
           <p:cNvPr id="3" name="Text 1">
             <a:extLst>
               <a:ext uri="{FF2B5EF4-FFF2-40B4-BE49-F238E27FC236}">
@@ -22603,7 +22420,7 @@
               <a:buNone/>
             </a:pPr>
             <a:r>
-              <a:rPr sz="4651" b="1" spc="-69" dirty="0">
+              <a:rPr lang="en-US" sz="4651" b="1" spc="-69" dirty="0">
                 <a:solidFill>
                   <a:srgbClr val="001F6B"/>
                 </a:solidFill>
@@ -22611,7 +22428,7 @@
                 <a:ea typeface="Frutiger"/>
                 <a:cs typeface="Frutiger"/>
               </a:rPr>
-              <a:t>State the rules next to the code</a:t>
+              <a:t>Tests</a:t>
             </a:r>
             <a:endParaRPr sz="4651" dirty="0"/>
           </a:p>
@@ -24101,7 +23918,7 @@
         </p:spPr>
         <p:txBody>
           <a:bodyPr wrap="square" lIns="0" tIns="0" rIns="0" bIns="0" anchor="t">
-            <a:normAutofit fontScale="92500"/>
+            <a:normAutofit/>
           </a:bodyPr>
           <a:lstStyle/>
           <a:p>
@@ -24160,7 +23977,27 @@
                 <a:latin typeface="Frutiger"/>
                 <a:cs typeface="Frutiger"/>
               </a:rPr>
-              <a:t>  check the model’s logic against rows you supply — e.g. “an order with one jaffle and one drink is both a food and a drink order”. Three ship with this project; confirm adapter support first.</a:t>
+              <a:t>  check the model’s logic against rows you </a:t>
+            </a:r>
+            <a:r>
+              <a:rPr lang="en-US" dirty="0">
+                <a:solidFill>
+                  <a:srgbClr val="364750"/>
+                </a:solidFill>
+                <a:latin typeface="Frutiger"/>
+                <a:cs typeface="Frutiger"/>
+              </a:rPr>
+              <a:t>provide</a:t>
+            </a:r>
+            <a:r>
+              <a:rPr lang="en-US" sz="1800" dirty="0">
+                <a:solidFill>
+                  <a:srgbClr val="364750"/>
+                </a:solidFill>
+                <a:latin typeface="Frutiger"/>
+                <a:cs typeface="Frutiger"/>
+              </a:rPr>
+              <a:t> e.g. “an order with one jaffle and one drink is both a food and a drink order”. Confirm adapter support first.</a:t>
             </a:r>
           </a:p>
           <a:p>
@@ -24191,7 +24028,7 @@
                 <a:latin typeface="Frutiger"/>
                 <a:cs typeface="Frutiger"/>
               </a:rPr>
-              <a:t>  are one-off SELECTs in data-tests/ — great for business reconciliations.</a:t>
+              <a:t>  are one-off SELECTs in data-tests/      Great for reconciliations!</a:t>
             </a:r>
           </a:p>
         </p:txBody>
@@ -24570,47 +24407,6 @@
           </a:prstGeom>
         </p:spPr>
       </p:pic>
-      <p:sp>
-        <p:nvSpPr>
-          <p:cNvPr id="100" name="Shape 100"/>
-          <p:cNvSpPr/>
-          <p:nvPr/>
-        </p:nvSpPr>
-        <p:spPr>
-          <a:xfrm>
-            <a:off x="838200" y="660400"/>
-            <a:ext cx="7620000" cy="355600"/>
-          </a:xfrm>
-          <a:prstGeom prst="rect">
-            <a:avLst/>
-          </a:prstGeom>
-          <a:noFill/>
-          <a:ln>
-            <a:noFill/>
-          </a:ln>
-        </p:spPr>
-        <p:txBody>
-          <a:bodyPr wrap="square" lIns="0" tIns="0" rIns="0" bIns="0" anchor="t">
-            <a:normAutofit/>
-          </a:bodyPr>
-          <a:lstStyle/>
-          <a:p>
-            <a:pPr>
-              <a:buNone/>
-            </a:pPr>
-            <a:r>
-              <a:rPr lang="en-US" sz="1500" b="1" spc="200" dirty="0">
-                <a:solidFill>
-                  <a:srgbClr val="E40046"/>
-                </a:solidFill>
-                <a:latin typeface="Frutiger"/>
-                <a:cs typeface="Frutiger"/>
-              </a:rPr>
-              <a:t>WHAT YOU’LL SEE  ·  ~9 MINUTES</a:t>
-            </a:r>
-          </a:p>
-        </p:txBody>
-      </p:sp>
       <p:sp>
         <p:nvSpPr>
           <p:cNvPr id="110" name="Shape 110"/>
@@ -26005,47 +25801,6 @@
       </p:pic>
       <p:sp>
         <p:nvSpPr>
-          <p:cNvPr id="100" name="Shape 100"/>
-          <p:cNvSpPr/>
-          <p:nvPr/>
-        </p:nvSpPr>
-        <p:spPr>
-          <a:xfrm>
-            <a:off x="838200" y="660400"/>
-            <a:ext cx="7620000" cy="355600"/>
-          </a:xfrm>
-          <a:prstGeom prst="rect">
-            <a:avLst/>
-          </a:prstGeom>
-          <a:noFill/>
-          <a:ln>
-            <a:noFill/>
-          </a:ln>
-        </p:spPr>
-        <p:txBody>
-          <a:bodyPr wrap="square" lIns="0" tIns="0" rIns="0" bIns="0" anchor="t">
-            <a:normAutofit/>
-          </a:bodyPr>
-          <a:lstStyle/>
-          <a:p>
-            <a:pPr>
-              <a:buNone/>
-            </a:pPr>
-            <a:r>
-              <a:rPr lang="en-US" sz="1500" b="1" spc="200" dirty="0">
-                <a:solidFill>
-                  <a:srgbClr val="E40046"/>
-                </a:solidFill>
-                <a:latin typeface="Frutiger"/>
-                <a:cs typeface="Frutiger"/>
-              </a:rPr>
-              <a:t>WHAT YOU’LL SEE  ·  ~9 MINUTES</a:t>
-            </a:r>
-          </a:p>
-        </p:txBody>
-      </p:sp>
-      <p:sp>
-        <p:nvSpPr>
           <p:cNvPr id="110" name="Shape 110"/>
           <p:cNvSpPr/>
           <p:nvPr/>
@@ -27052,7 +26807,7 @@
                 <a:latin typeface="Frutiger"/>
                 <a:cs typeface="Frutiger"/>
               </a:rPr>
-              <a:t>A green build proves</a:t>
+              <a:t>A green build </a:t>
             </a:r>
           </a:p>
         </p:txBody>

</xml_diff>